<commit_message>
adds subnetting slide to networking
</commit_message>
<xml_diff>
--- a/Intro to Computers/Lesson 02 - Networking Basics/Lesson 2 - Network Basics.pptx
+++ b/Intro to Computers/Lesson 02 - Networking Basics/Lesson 2 - Network Basics.pptx
@@ -5,7 +5,7 @@
     <p:sldMasterId id="2147483664" r:id="rId1"/>
   </p:sldMasterIdLst>
   <p:notesMasterIdLst>
-    <p:notesMasterId r:id="rId21"/>
+    <p:notesMasterId r:id="rId22"/>
   </p:notesMasterIdLst>
   <p:sldIdLst>
     <p:sldId id="256" r:id="rId2"/>
@@ -17,16 +17,17 @@
     <p:sldId id="298" r:id="rId8"/>
     <p:sldId id="300" r:id="rId9"/>
     <p:sldId id="299" r:id="rId10"/>
-    <p:sldId id="303" r:id="rId11"/>
-    <p:sldId id="301" r:id="rId12"/>
-    <p:sldId id="302" r:id="rId13"/>
-    <p:sldId id="305" r:id="rId14"/>
-    <p:sldId id="307" r:id="rId15"/>
-    <p:sldId id="308" r:id="rId16"/>
-    <p:sldId id="311" r:id="rId17"/>
-    <p:sldId id="304" r:id="rId18"/>
-    <p:sldId id="309" r:id="rId19"/>
-    <p:sldId id="310" r:id="rId20"/>
+    <p:sldId id="313" r:id="rId11"/>
+    <p:sldId id="303" r:id="rId12"/>
+    <p:sldId id="301" r:id="rId13"/>
+    <p:sldId id="302" r:id="rId14"/>
+    <p:sldId id="305" r:id="rId15"/>
+    <p:sldId id="307" r:id="rId16"/>
+    <p:sldId id="308" r:id="rId17"/>
+    <p:sldId id="311" r:id="rId18"/>
+    <p:sldId id="304" r:id="rId19"/>
+    <p:sldId id="309" r:id="rId20"/>
+    <p:sldId id="310" r:id="rId21"/>
   </p:sldIdLst>
   <p:sldSz cx="9144000" cy="5143500" type="screen16x9"/>
   <p:notesSz cx="6858000" cy="9144000"/>
@@ -890,7 +891,12 @@
             <p:ph type="sldImg"/>
           </p:nvPr>
         </p:nvSpPr>
-        <p:spPr/>
+        <p:spPr>
+          <a:xfrm>
+            <a:off x="381000" y="685800"/>
+            <a:ext cx="6096000" cy="3429000"/>
+          </a:xfrm>
+        </p:spPr>
       </p:sp>
       <p:sp>
         <p:nvSpPr>
@@ -907,14 +913,17 @@
           <a:bodyPr/>
           <a:lstStyle/>
           <a:p>
-            <a:endParaRPr lang="en-US" dirty="0"/>
+            <a:r>
+              <a:rPr lang="en-US" dirty="0"/>
+              <a:t>Subnetting allows us to split one larger network into multiple, smaller networks.</a:t>
+            </a:r>
           </a:p>
         </p:txBody>
       </p:sp>
     </p:spTree>
     <p:extLst>
       <p:ext uri="{BB962C8B-B14F-4D97-AF65-F5344CB8AC3E}">
-        <p14:creationId xmlns:p14="http://schemas.microsoft.com/office/powerpoint/2010/main" val="1766816439"/>
+        <p14:creationId xmlns:p14="http://schemas.microsoft.com/office/powerpoint/2010/main" val="3696674434"/>
       </p:ext>
     </p:extLst>
   </p:cSld>
@@ -975,6 +984,67 @@
     </p:spTree>
     <p:extLst>
       <p:ext uri="{BB962C8B-B14F-4D97-AF65-F5344CB8AC3E}">
+        <p14:creationId xmlns:p14="http://schemas.microsoft.com/office/powerpoint/2010/main" val="1766816439"/>
+      </p:ext>
+    </p:extLst>
+  </p:cSld>
+  <p:clrMapOvr>
+    <a:masterClrMapping/>
+  </p:clrMapOvr>
+</p:notes>
+</file>
+
+<file path=ppt/notesSlides/notesSlide5.xml><?xml version="1.0" encoding="utf-8"?>
+<p:notes xmlns:a="http://schemas.openxmlformats.org/drawingml/2006/main" xmlns:r="http://schemas.openxmlformats.org/officeDocument/2006/relationships" xmlns:p="http://schemas.openxmlformats.org/presentationml/2006/main">
+  <p:cSld>
+    <p:spTree>
+      <p:nvGrpSpPr>
+        <p:cNvPr id="1" name=""/>
+        <p:cNvGrpSpPr/>
+        <p:nvPr/>
+      </p:nvGrpSpPr>
+      <p:grpSpPr>
+        <a:xfrm>
+          <a:off x="0" y="0"/>
+          <a:ext cx="0" cy="0"/>
+          <a:chOff x="0" y="0"/>
+          <a:chExt cx="0" cy="0"/>
+        </a:xfrm>
+      </p:grpSpPr>
+      <p:sp>
+        <p:nvSpPr>
+          <p:cNvPr id="2" name="Slide Image Placeholder 1"/>
+          <p:cNvSpPr>
+            <a:spLocks noGrp="1" noRot="1" noChangeAspect="1"/>
+          </p:cNvSpPr>
+          <p:nvPr>
+            <p:ph type="sldImg"/>
+          </p:nvPr>
+        </p:nvSpPr>
+        <p:spPr/>
+      </p:sp>
+      <p:sp>
+        <p:nvSpPr>
+          <p:cNvPr id="3" name="Notes Placeholder 2"/>
+          <p:cNvSpPr>
+            <a:spLocks noGrp="1"/>
+          </p:cNvSpPr>
+          <p:nvPr>
+            <p:ph type="body" idx="1"/>
+          </p:nvPr>
+        </p:nvSpPr>
+        <p:spPr/>
+        <p:txBody>
+          <a:bodyPr/>
+          <a:lstStyle/>
+          <a:p>
+            <a:endParaRPr lang="en-US" dirty="0"/>
+          </a:p>
+        </p:txBody>
+      </p:sp>
+    </p:spTree>
+    <p:extLst>
+      <p:ext uri="{BB962C8B-B14F-4D97-AF65-F5344CB8AC3E}">
         <p14:creationId xmlns:p14="http://schemas.microsoft.com/office/powerpoint/2010/main" val="1511459655"/>
       </p:ext>
     </p:extLst>
@@ -985,7 +1055,7 @@
 </p:notes>
 </file>
 
-<file path=ppt/notesSlides/notesSlide5.xml><?xml version="1.0" encoding="utf-8"?>
+<file path=ppt/notesSlides/notesSlide6.xml><?xml version="1.0" encoding="utf-8"?>
 <p:notes xmlns:a="http://schemas.openxmlformats.org/drawingml/2006/main" xmlns:r="http://schemas.openxmlformats.org/officeDocument/2006/relationships" xmlns:p="http://schemas.openxmlformats.org/presentationml/2006/main">
   <p:cSld>
     <p:spTree>
@@ -1102,7 +1172,7 @@
           <a:p>
             <a:fld id="{7A3E0868-4E26-4CDC-8A56-D70E2D8B12FE}" type="datetime3">
               <a:rPr lang="en-US" smtClean="0"/>
-              <a:t>25 March 2026</a:t>
+              <a:t>7 April 2026</a:t>
             </a:fld>
             <a:endParaRPr lang="en-US"/>
           </a:p>
@@ -3679,7 +3749,7 @@
           <a:p>
             <a:fld id="{A7B8021B-6105-4216-96FC-94348F216D0E}" type="datetime3">
               <a:rPr lang="en-US" smtClean="0"/>
-              <a:t>25 March 2026</a:t>
+              <a:t>7 April 2026</a:t>
             </a:fld>
             <a:endParaRPr lang="en-US"/>
           </a:p>
@@ -5377,7 +5447,7 @@
           <a:p>
             <a:fld id="{5D27CFAB-73E6-44A8-B862-B3306344E3F2}" type="datetime3">
               <a:rPr lang="en-US" smtClean="0"/>
-              <a:t>25 March 2026</a:t>
+              <a:t>7 April 2026</a:t>
             </a:fld>
             <a:endParaRPr lang="en-US"/>
           </a:p>
@@ -7168,7 +7238,7 @@
           <a:p>
             <a:fld id="{A9B2E784-A5F5-4301-881B-94AC8DBF9DED}" type="datetime3">
               <a:rPr lang="en-US" smtClean="0"/>
-              <a:t>25 March 2026</a:t>
+              <a:t>7 April 2026</a:t>
             </a:fld>
             <a:endParaRPr lang="en-US"/>
           </a:p>
@@ -7348,7 +7418,7 @@
           <a:p>
             <a:fld id="{18EAB3A5-9E92-4BB9-8F22-9632B4FBEDBA}" type="datetime3">
               <a:rPr lang="en-US" smtClean="0"/>
-              <a:t>25 March 2026</a:t>
+              <a:t>7 April 2026</a:t>
             </a:fld>
             <a:endParaRPr lang="en-US"/>
           </a:p>
@@ -7576,7 +7646,7 @@
           <a:p>
             <a:fld id="{40923810-5FB2-48C9-96CA-1DE2C4773142}" type="datetime3">
               <a:rPr lang="en-US" smtClean="0"/>
-              <a:t>25 March 2026</a:t>
+              <a:t>7 April 2026</a:t>
             </a:fld>
             <a:endParaRPr lang="en-US"/>
           </a:p>
@@ -7867,7 +7937,7 @@
           <a:p>
             <a:fld id="{E50EFF4B-86EB-42FB-93EA-7D8F9CB2466F}" type="datetime3">
               <a:rPr lang="en-US" smtClean="0"/>
-              <a:t>25 March 2026</a:t>
+              <a:t>7 April 2026</a:t>
             </a:fld>
             <a:endParaRPr lang="en-US"/>
           </a:p>
@@ -8480,7 +8550,7 @@
           <a:p>
             <a:fld id="{FB14FC24-E041-45E9-9A72-E5755A86890F}" type="datetime3">
               <a:rPr lang="en-US" smtClean="0"/>
-              <a:t>25 March 2026</a:t>
+              <a:t>7 April 2026</a:t>
             </a:fld>
             <a:endParaRPr lang="en-US"/>
           </a:p>
@@ -9341,7 +9411,7 @@
           <a:p>
             <a:fld id="{98A19125-94A7-4474-858C-FD9C4ABE9DDA}" type="datetime3">
               <a:rPr lang="en-US" smtClean="0"/>
-              <a:t>25 March 2026</a:t>
+              <a:t>7 April 2026</a:t>
             </a:fld>
             <a:endParaRPr lang="en-US"/>
           </a:p>
@@ -10445,7 +10515,7 @@
           <a:p>
             <a:fld id="{3BA0343D-C8D8-43CE-BB79-50DEA219DB07}" type="datetime3">
               <a:rPr lang="en-US" smtClean="0"/>
-              <a:t>25 March 2026</a:t>
+              <a:t>7 April 2026</a:t>
             </a:fld>
             <a:endParaRPr lang="en-US"/>
           </a:p>
@@ -10735,7 +10805,7 @@
           <a:p>
             <a:fld id="{453BD212-0B9F-4987-965F-AC83B2FC354F}" type="datetime3">
               <a:rPr lang="en-US" smtClean="0"/>
-              <a:t>25 March 2026</a:t>
+              <a:t>7 April 2026</a:t>
             </a:fld>
             <a:endParaRPr lang="en-US"/>
           </a:p>
@@ -10979,7 +11049,7 @@
           <a:p>
             <a:fld id="{6DDC931E-8CBE-4A3F-A034-9B6122C6DCDB}" type="datetime3">
               <a:rPr lang="en-US" smtClean="0"/>
-              <a:t>25 March 2026</a:t>
+              <a:t>7 April 2026</a:t>
             </a:fld>
             <a:endParaRPr lang="en-US"/>
           </a:p>
@@ -12762,7 +12832,7 @@
           <a:p>
             <a:fld id="{220AF9C2-5E8A-4308-AE6B-CA9B65007D0E}" type="datetime3">
               <a:rPr lang="en-US" smtClean="0"/>
-              <a:t>25 March 2026</a:t>
+              <a:t>7 April 2026</a:t>
             </a:fld>
             <a:endParaRPr lang="en-US"/>
           </a:p>
@@ -13076,7 +13146,7 @@
           <a:p>
             <a:fld id="{FF31E861-D2AF-431D-860B-DCF67C218052}" type="datetime3">
               <a:rPr lang="en-US" smtClean="0"/>
-              <a:t>25 March 2026</a:t>
+              <a:t>7 April 2026</a:t>
             </a:fld>
             <a:endParaRPr lang="en-US"/>
           </a:p>
@@ -13356,7 +13426,7 @@
           <a:p>
             <a:fld id="{D1DA25B2-AAF1-4C1F-AA38-12D5BFA7D4C8}" type="datetime3">
               <a:rPr lang="en-US" smtClean="0"/>
-              <a:t>25 March 2026</a:t>
+              <a:t>7 April 2026</a:t>
             </a:fld>
             <a:endParaRPr lang="en-US"/>
           </a:p>
@@ -13636,7 +13706,7 @@
           <a:p>
             <a:fld id="{A25C0F39-45D0-48E9-90B3-7FE8FCE561C8}" type="datetime3">
               <a:rPr lang="en-US" smtClean="0"/>
-              <a:t>25 March 2026</a:t>
+              <a:t>7 April 2026</a:t>
             </a:fld>
             <a:endParaRPr lang="en-US"/>
           </a:p>
@@ -14138,7 +14208,7 @@
           <a:p>
             <a:fld id="{9BAF1A3D-92FA-4F24-9781-74AFA516A230}" type="datetime3">
               <a:rPr lang="en-US" smtClean="0"/>
-              <a:t>25 March 2026</a:t>
+              <a:t>7 April 2026</a:t>
             </a:fld>
             <a:endParaRPr lang="en-US"/>
           </a:p>
@@ -14266,7 +14336,7 @@
           <a:p>
             <a:fld id="{5719C672-856D-4617-A693-8FE15749A9B7}" type="datetime3">
               <a:rPr lang="en-US" smtClean="0"/>
-              <a:t>25 March 2026</a:t>
+              <a:t>7 April 2026</a:t>
             </a:fld>
             <a:endParaRPr lang="en-US"/>
           </a:p>
@@ -14402,7 +14472,7 @@
           <a:p>
             <a:fld id="{5F6C764D-A39E-4C03-B161-E0BC66E8883B}" type="datetime3">
               <a:rPr lang="en-US" smtClean="0"/>
-              <a:t>25 March 2026</a:t>
+              <a:t>7 April 2026</a:t>
             </a:fld>
             <a:endParaRPr lang="en-US"/>
           </a:p>
@@ -14641,7 +14711,7 @@
           <a:p>
             <a:fld id="{6E3E33F9-20B7-4995-BE7D-165DBB597850}" type="datetime3">
               <a:rPr lang="en-US" smtClean="0"/>
-              <a:t>25 March 2026</a:t>
+              <a:t>7 April 2026</a:t>
             </a:fld>
             <a:endParaRPr lang="en-US"/>
           </a:p>
@@ -14755,7 +14825,7 @@
           <a:p>
             <a:fld id="{CD41C263-3501-4369-A962-62B6BF915CDE}" type="datetime3">
               <a:rPr lang="en-US" smtClean="0"/>
-              <a:t>25 March 2026</a:t>
+              <a:t>7 April 2026</a:t>
             </a:fld>
             <a:endParaRPr lang="en-US"/>
           </a:p>
@@ -15159,7 +15229,7 @@
           <a:p>
             <a:fld id="{B06F3EBE-B2E8-4992-9F00-9E4B44F057C0}" type="datetime3">
               <a:rPr lang="en-US" smtClean="0"/>
-              <a:t>25 March 2026</a:t>
+              <a:t>7 April 2026</a:t>
             </a:fld>
             <a:endParaRPr lang="en-US"/>
           </a:p>
@@ -15292,7 +15362,7 @@
           <a:p>
             <a:fld id="{D41656AB-D2E1-472E-8B95-0DF5C6E1D623}" type="datetime3">
               <a:rPr lang="en-US" smtClean="0"/>
-              <a:t>25 March 2026</a:t>
+              <a:t>7 April 2026</a:t>
             </a:fld>
             <a:endParaRPr lang="en-US"/>
           </a:p>
@@ -17200,7 +17270,7 @@
           <a:p>
             <a:fld id="{AD622D1A-DF83-41A8-85FF-04D90BF831D3}" type="datetime3">
               <a:rPr lang="en-US" smtClean="0"/>
-              <a:t>25 March 2026</a:t>
+              <a:t>7 April 2026</a:t>
             </a:fld>
             <a:endParaRPr lang="en-US"/>
           </a:p>
@@ -17451,7 +17521,7 @@
           <a:p>
             <a:fld id="{334F72C3-CDF3-44A8-B602-1649B1728485}" type="datetime3">
               <a:rPr lang="en-US" smtClean="0"/>
-              <a:t>25 March 2026</a:t>
+              <a:t>7 April 2026</a:t>
             </a:fld>
             <a:endParaRPr lang="en-US"/>
           </a:p>
@@ -17759,7 +17829,7 @@
           <a:p>
             <a:fld id="{1E0132BA-B5E7-4FFD-AF6C-169169D47D4A}" type="datetime3">
               <a:rPr lang="en-US" smtClean="0"/>
-              <a:t>25 March 2026</a:t>
+              <a:t>7 April 2026</a:t>
             </a:fld>
             <a:endParaRPr lang="en-US"/>
           </a:p>
@@ -18241,7 +18311,7 @@
           <a:p>
             <a:fld id="{81A30091-1C2A-4151-8D3C-D1E47A72615F}" type="datetime3">
               <a:rPr lang="en-US" smtClean="0"/>
-              <a:t>25 March 2026</a:t>
+              <a:t>7 April 2026</a:t>
             </a:fld>
             <a:endParaRPr lang="en-US"/>
           </a:p>
@@ -18879,7 +18949,7 @@
           <a:p>
             <a:fld id="{35D703CE-07B4-4C05-A488-B4566700621F}" type="datetime3">
               <a:rPr lang="en-US" smtClean="0"/>
-              <a:t>25 March 2026</a:t>
+              <a:t>7 April 2026</a:t>
             </a:fld>
             <a:endParaRPr lang="en-US"/>
           </a:p>
@@ -19938,7 +20008,7 @@
           <a:p>
             <a:fld id="{694BD61C-20BA-43AF-A21F-1DAFB3200099}" type="datetime3">
               <a:rPr lang="en-US" smtClean="0"/>
-              <a:t>25 March 2026</a:t>
+              <a:t>7 April 2026</a:t>
             </a:fld>
             <a:endParaRPr lang="en-US"/>
           </a:p>
@@ -20427,7 +20497,7 @@
           <a:p>
             <a:fld id="{CABCB1B0-B6E5-4DD1-BB55-95C076D6C0C8}" type="datetime3">
               <a:rPr lang="en-US" smtClean="0"/>
-              <a:t>25 March 2026</a:t>
+              <a:t>7 April 2026</a:t>
             </a:fld>
             <a:endParaRPr lang="en-US"/>
           </a:p>
@@ -20978,7 +21048,7 @@
           <a:p>
             <a:fld id="{7A3E0868-4E26-4CDC-8A56-D70E2D8B12FE}" type="datetime3">
               <a:rPr lang="en-US" smtClean="0"/>
-              <a:t>25 March 2026</a:t>
+              <a:t>7 April 2026</a:t>
             </a:fld>
             <a:endParaRPr lang="en-US"/>
           </a:p>
@@ -21356,6 +21426,133 @@
 </file>
 
 <file path=ppt/slides/slide10.xml><?xml version="1.0" encoding="utf-8"?>
+<p:sld xmlns:a="http://schemas.openxmlformats.org/drawingml/2006/main" xmlns:r="http://schemas.openxmlformats.org/officeDocument/2006/relationships" xmlns:p="http://schemas.openxmlformats.org/presentationml/2006/main">
+  <p:cSld>
+    <p:spTree>
+      <p:nvGrpSpPr>
+        <p:cNvPr id="1" name=""/>
+        <p:cNvGrpSpPr/>
+        <p:nvPr/>
+      </p:nvGrpSpPr>
+      <p:grpSpPr>
+        <a:xfrm>
+          <a:off x="0" y="0"/>
+          <a:ext cx="0" cy="0"/>
+          <a:chOff x="0" y="0"/>
+          <a:chExt cx="0" cy="0"/>
+        </a:xfrm>
+      </p:grpSpPr>
+      <p:sp>
+        <p:nvSpPr>
+          <p:cNvPr id="3" name="Content Placeholder 2">
+            <a:extLst>
+              <a:ext uri="{FF2B5EF4-FFF2-40B4-BE49-F238E27FC236}">
+                <a16:creationId xmlns:a16="http://schemas.microsoft.com/office/drawing/2014/main" id="{53282ADB-713B-DD03-B1E1-B9A1B1CADE49}"/>
+              </a:ext>
+            </a:extLst>
+          </p:cNvPr>
+          <p:cNvSpPr>
+            <a:spLocks noGrp="1"/>
+          </p:cNvSpPr>
+          <p:nvPr>
+            <p:ph sz="half" idx="1"/>
+          </p:nvPr>
+        </p:nvSpPr>
+        <p:spPr/>
+        <p:txBody>
+          <a:bodyPr/>
+          <a:lstStyle/>
+          <a:p>
+            <a:endParaRPr lang="en-US" dirty="0"/>
+          </a:p>
+        </p:txBody>
+      </p:sp>
+      <p:sp>
+        <p:nvSpPr>
+          <p:cNvPr id="4" name="Content Placeholder 3">
+            <a:extLst>
+              <a:ext uri="{FF2B5EF4-FFF2-40B4-BE49-F238E27FC236}">
+                <a16:creationId xmlns:a16="http://schemas.microsoft.com/office/drawing/2014/main" id="{80927216-FE3C-ADAD-2201-AE69726FC2D9}"/>
+              </a:ext>
+            </a:extLst>
+          </p:cNvPr>
+          <p:cNvSpPr>
+            <a:spLocks noGrp="1"/>
+          </p:cNvSpPr>
+          <p:nvPr>
+            <p:ph sz="half" idx="2"/>
+          </p:nvPr>
+        </p:nvSpPr>
+        <p:spPr/>
+        <p:txBody>
+          <a:bodyPr/>
+          <a:lstStyle/>
+          <a:p>
+            <a:endParaRPr lang="en-US"/>
+          </a:p>
+        </p:txBody>
+      </p:sp>
+      <p:pic>
+        <p:nvPicPr>
+          <p:cNvPr id="1026" name="Picture 2" descr="What Is a Subnet (Subnetwork)? Subnetting Explained">
+            <a:extLst>
+              <a:ext uri="{FF2B5EF4-FFF2-40B4-BE49-F238E27FC236}">
+                <a16:creationId xmlns:a16="http://schemas.microsoft.com/office/drawing/2014/main" id="{390C059F-24A7-00BC-28CD-288759792D1F}"/>
+              </a:ext>
+            </a:extLst>
+          </p:cNvPr>
+          <p:cNvPicPr>
+            <a:picLocks noChangeAspect="1" noChangeArrowheads="1"/>
+          </p:cNvPicPr>
+          <p:nvPr/>
+        </p:nvPicPr>
+        <p:blipFill>
+          <a:blip r:embed="rId3">
+            <a:extLst>
+              <a:ext uri="{28A0092B-C50C-407E-A947-70E740481C1C}">
+                <a14:useLocalDpi xmlns:a14="http://schemas.microsoft.com/office/drawing/2010/main" val="0"/>
+              </a:ext>
+            </a:extLst>
+          </a:blip>
+          <a:srcRect/>
+          <a:stretch>
+            <a:fillRect/>
+          </a:stretch>
+        </p:blipFill>
+        <p:spPr bwMode="auto">
+          <a:xfrm>
+            <a:off x="761654" y="651511"/>
+            <a:ext cx="7620000" cy="4067175"/>
+          </a:xfrm>
+          <a:prstGeom prst="rect">
+            <a:avLst/>
+          </a:prstGeom>
+          <a:noFill/>
+          <a:extLst>
+            <a:ext uri="{909E8E84-426E-40DD-AFC4-6F175D3DCCD1}">
+              <a14:hiddenFill xmlns:a14="http://schemas.microsoft.com/office/drawing/2010/main">
+                <a:solidFill>
+                  <a:srgbClr val="FFFFFF"/>
+                </a:solidFill>
+              </a14:hiddenFill>
+            </a:ext>
+          </a:extLst>
+        </p:spPr>
+      </p:pic>
+    </p:spTree>
+    <p:extLst>
+      <p:ext uri="{BB962C8B-B14F-4D97-AF65-F5344CB8AC3E}">
+        <p14:creationId xmlns:p14="http://schemas.microsoft.com/office/powerpoint/2010/main" val="128763598"/>
+      </p:ext>
+    </p:extLst>
+  </p:cSld>
+  <p:clrMapOvr>
+    <a:masterClrMapping/>
+  </p:clrMapOvr>
+</p:sld>
+</file>
+
+<file path=ppt/slides/slide11.xml><?xml version="1.0" encoding="utf-8"?>
 <p:sld xmlns:a="http://schemas.openxmlformats.org/drawingml/2006/main" xmlns:r="http://schemas.openxmlformats.org/officeDocument/2006/relationships" xmlns:p="http://schemas.openxmlformats.org/presentationml/2006/main">
   <p:cSld>
     <p:spTree>
@@ -22541,7 +22738,7 @@
 </p:sld>
 </file>
 
-<file path=ppt/slides/slide11.xml><?xml version="1.0" encoding="utf-8"?>
+<file path=ppt/slides/slide12.xml><?xml version="1.0" encoding="utf-8"?>
 <p:sld xmlns:a="http://schemas.openxmlformats.org/drawingml/2006/main" xmlns:r="http://schemas.openxmlformats.org/officeDocument/2006/relationships" xmlns:p="http://schemas.openxmlformats.org/presentationml/2006/main">
   <p:cSld>
     <p:spTree>
@@ -22892,7 +23089,7 @@
 </p:sld>
 </file>
 
-<file path=ppt/slides/slide12.xml><?xml version="1.0" encoding="utf-8"?>
+<file path=ppt/slides/slide13.xml><?xml version="1.0" encoding="utf-8"?>
 <p:sld xmlns:a="http://schemas.openxmlformats.org/drawingml/2006/main" xmlns:r="http://schemas.openxmlformats.org/officeDocument/2006/relationships" xmlns:p="http://schemas.openxmlformats.org/presentationml/2006/main">
   <p:cSld>
     <p:spTree>
@@ -23383,7 +23580,7 @@
 </p:sld>
 </file>
 
-<file path=ppt/slides/slide13.xml><?xml version="1.0" encoding="utf-8"?>
+<file path=ppt/slides/slide14.xml><?xml version="1.0" encoding="utf-8"?>
 <p:sld xmlns:a="http://schemas.openxmlformats.org/drawingml/2006/main" xmlns:r="http://schemas.openxmlformats.org/officeDocument/2006/relationships" xmlns:p="http://schemas.openxmlformats.org/presentationml/2006/main">
   <p:cSld>
     <p:spTree>
@@ -23472,7 +23669,7 @@
 </p:sld>
 </file>
 
-<file path=ppt/slides/slide14.xml><?xml version="1.0" encoding="utf-8"?>
+<file path=ppt/slides/slide15.xml><?xml version="1.0" encoding="utf-8"?>
 <p:sld xmlns:a="http://schemas.openxmlformats.org/drawingml/2006/main" xmlns:r="http://schemas.openxmlformats.org/officeDocument/2006/relationships" xmlns:p="http://schemas.openxmlformats.org/presentationml/2006/main">
   <p:cSld>
     <p:spTree>
@@ -23664,7 +23861,7 @@
 </p:sld>
 </file>
 
-<file path=ppt/slides/slide15.xml><?xml version="1.0" encoding="utf-8"?>
+<file path=ppt/slides/slide16.xml><?xml version="1.0" encoding="utf-8"?>
 <p:sld xmlns:a="http://schemas.openxmlformats.org/drawingml/2006/main" xmlns:r="http://schemas.openxmlformats.org/officeDocument/2006/relationships" xmlns:p="http://schemas.openxmlformats.org/presentationml/2006/main">
   <p:cSld>
     <p:spTree>
@@ -25997,7 +26194,7 @@
 </p:sld>
 </file>
 
-<file path=ppt/slides/slide16.xml><?xml version="1.0" encoding="utf-8"?>
+<file path=ppt/slides/slide17.xml><?xml version="1.0" encoding="utf-8"?>
 <p:sld xmlns:a="http://schemas.openxmlformats.org/drawingml/2006/main" xmlns:r="http://schemas.openxmlformats.org/officeDocument/2006/relationships" xmlns:p="http://schemas.openxmlformats.org/presentationml/2006/main">
   <p:cSld>
     <p:spTree>
@@ -26288,7 +26485,7 @@
 </p:sld>
 </file>
 
-<file path=ppt/slides/slide17.xml><?xml version="1.0" encoding="utf-8"?>
+<file path=ppt/slides/slide18.xml><?xml version="1.0" encoding="utf-8"?>
 <p:sld xmlns:a="http://schemas.openxmlformats.org/drawingml/2006/main" xmlns:r="http://schemas.openxmlformats.org/officeDocument/2006/relationships" xmlns:p="http://schemas.openxmlformats.org/presentationml/2006/main">
   <p:cSld>
     <p:spTree>
@@ -26441,7 +26638,7 @@
 </p:sld>
 </file>
 
-<file path=ppt/slides/slide18.xml><?xml version="1.0" encoding="utf-8"?>
+<file path=ppt/slides/slide19.xml><?xml version="1.0" encoding="utf-8"?>
 <p:sld xmlns:a="http://schemas.openxmlformats.org/drawingml/2006/main" xmlns:r="http://schemas.openxmlformats.org/officeDocument/2006/relationships" xmlns:p="http://schemas.openxmlformats.org/presentationml/2006/main">
   <p:cSld>
     <p:spTree>
@@ -28850,95 +29047,6 @@
     <p:extLst>
       <p:ext uri="{BB962C8B-B14F-4D97-AF65-F5344CB8AC3E}">
         <p14:creationId xmlns:p14="http://schemas.microsoft.com/office/powerpoint/2010/main" val="692596205"/>
-      </p:ext>
-    </p:extLst>
-  </p:cSld>
-  <p:clrMapOvr>
-    <a:masterClrMapping/>
-  </p:clrMapOvr>
-</p:sld>
-</file>
-
-<file path=ppt/slides/slide19.xml><?xml version="1.0" encoding="utf-8"?>
-<p:sld xmlns:a="http://schemas.openxmlformats.org/drawingml/2006/main" xmlns:r="http://schemas.openxmlformats.org/officeDocument/2006/relationships" xmlns:p="http://schemas.openxmlformats.org/presentationml/2006/main">
-  <p:cSld>
-    <p:spTree>
-      <p:nvGrpSpPr>
-        <p:cNvPr id="1" name="">
-          <a:extLst>
-            <a:ext uri="{FF2B5EF4-FFF2-40B4-BE49-F238E27FC236}">
-              <a16:creationId xmlns:a16="http://schemas.microsoft.com/office/drawing/2014/main" id="{881D063C-59E5-F41F-82F5-135DA6BC0E04}"/>
-            </a:ext>
-          </a:extLst>
-        </p:cNvPr>
-        <p:cNvGrpSpPr/>
-        <p:nvPr/>
-      </p:nvGrpSpPr>
-      <p:grpSpPr>
-        <a:xfrm>
-          <a:off x="0" y="0"/>
-          <a:ext cx="0" cy="0"/>
-          <a:chOff x="0" y="0"/>
-          <a:chExt cx="0" cy="0"/>
-        </a:xfrm>
-      </p:grpSpPr>
-      <p:sp>
-        <p:nvSpPr>
-          <p:cNvPr id="20" name="Title 19">
-            <a:extLst>
-              <a:ext uri="{FF2B5EF4-FFF2-40B4-BE49-F238E27FC236}">
-                <a16:creationId xmlns:a16="http://schemas.microsoft.com/office/drawing/2014/main" id="{20E7A09F-5C12-6310-B6EF-B3FF09F303C6}"/>
-              </a:ext>
-            </a:extLst>
-          </p:cNvPr>
-          <p:cNvSpPr>
-            <a:spLocks noGrp="1"/>
-          </p:cNvSpPr>
-          <p:nvPr>
-            <p:ph type="title"/>
-          </p:nvPr>
-        </p:nvSpPr>
-        <p:spPr/>
-        <p:txBody>
-          <a:bodyPr/>
-          <a:lstStyle/>
-          <a:p>
-            <a:r>
-              <a:rPr lang="en-US" dirty="0"/>
-              <a:t>Questions</a:t>
-            </a:r>
-          </a:p>
-        </p:txBody>
-      </p:sp>
-      <p:sp>
-        <p:nvSpPr>
-          <p:cNvPr id="21" name="Content Placeholder 20">
-            <a:extLst>
-              <a:ext uri="{FF2B5EF4-FFF2-40B4-BE49-F238E27FC236}">
-                <a16:creationId xmlns:a16="http://schemas.microsoft.com/office/drawing/2014/main" id="{18C1BF79-2C65-E4D5-6B54-962768A25E32}"/>
-              </a:ext>
-            </a:extLst>
-          </p:cNvPr>
-          <p:cNvSpPr>
-            <a:spLocks noGrp="1"/>
-          </p:cNvSpPr>
-          <p:nvPr>
-            <p:ph sz="half" idx="1"/>
-          </p:nvPr>
-        </p:nvSpPr>
-        <p:spPr/>
-        <p:txBody>
-          <a:bodyPr/>
-          <a:lstStyle/>
-          <a:p>
-            <a:endParaRPr lang="en-US"/>
-          </a:p>
-        </p:txBody>
-      </p:sp>
-    </p:spTree>
-    <p:extLst>
-      <p:ext uri="{BB962C8B-B14F-4D97-AF65-F5344CB8AC3E}">
-        <p14:creationId xmlns:p14="http://schemas.microsoft.com/office/powerpoint/2010/main" val="798466600"/>
       </p:ext>
     </p:extLst>
   </p:cSld>
@@ -29326,6 +29434,95 @@
       <p:bldP spid="7" grpId="1"/>
     </p:bldLst>
   </p:timing>
+</p:sld>
+</file>
+
+<file path=ppt/slides/slide20.xml><?xml version="1.0" encoding="utf-8"?>
+<p:sld xmlns:a="http://schemas.openxmlformats.org/drawingml/2006/main" xmlns:r="http://schemas.openxmlformats.org/officeDocument/2006/relationships" xmlns:p="http://schemas.openxmlformats.org/presentationml/2006/main">
+  <p:cSld>
+    <p:spTree>
+      <p:nvGrpSpPr>
+        <p:cNvPr id="1" name="">
+          <a:extLst>
+            <a:ext uri="{FF2B5EF4-FFF2-40B4-BE49-F238E27FC236}">
+              <a16:creationId xmlns:a16="http://schemas.microsoft.com/office/drawing/2014/main" id="{881D063C-59E5-F41F-82F5-135DA6BC0E04}"/>
+            </a:ext>
+          </a:extLst>
+        </p:cNvPr>
+        <p:cNvGrpSpPr/>
+        <p:nvPr/>
+      </p:nvGrpSpPr>
+      <p:grpSpPr>
+        <a:xfrm>
+          <a:off x="0" y="0"/>
+          <a:ext cx="0" cy="0"/>
+          <a:chOff x="0" y="0"/>
+          <a:chExt cx="0" cy="0"/>
+        </a:xfrm>
+      </p:grpSpPr>
+      <p:sp>
+        <p:nvSpPr>
+          <p:cNvPr id="20" name="Title 19">
+            <a:extLst>
+              <a:ext uri="{FF2B5EF4-FFF2-40B4-BE49-F238E27FC236}">
+                <a16:creationId xmlns:a16="http://schemas.microsoft.com/office/drawing/2014/main" id="{20E7A09F-5C12-6310-B6EF-B3FF09F303C6}"/>
+              </a:ext>
+            </a:extLst>
+          </p:cNvPr>
+          <p:cNvSpPr>
+            <a:spLocks noGrp="1"/>
+          </p:cNvSpPr>
+          <p:nvPr>
+            <p:ph type="title"/>
+          </p:nvPr>
+        </p:nvSpPr>
+        <p:spPr/>
+        <p:txBody>
+          <a:bodyPr/>
+          <a:lstStyle/>
+          <a:p>
+            <a:r>
+              <a:rPr lang="en-US" dirty="0"/>
+              <a:t>Questions</a:t>
+            </a:r>
+          </a:p>
+        </p:txBody>
+      </p:sp>
+      <p:sp>
+        <p:nvSpPr>
+          <p:cNvPr id="21" name="Content Placeholder 20">
+            <a:extLst>
+              <a:ext uri="{FF2B5EF4-FFF2-40B4-BE49-F238E27FC236}">
+                <a16:creationId xmlns:a16="http://schemas.microsoft.com/office/drawing/2014/main" id="{18C1BF79-2C65-E4D5-6B54-962768A25E32}"/>
+              </a:ext>
+            </a:extLst>
+          </p:cNvPr>
+          <p:cNvSpPr>
+            <a:spLocks noGrp="1"/>
+          </p:cNvSpPr>
+          <p:nvPr>
+            <p:ph sz="half" idx="1"/>
+          </p:nvPr>
+        </p:nvSpPr>
+        <p:spPr/>
+        <p:txBody>
+          <a:bodyPr/>
+          <a:lstStyle/>
+          <a:p>
+            <a:endParaRPr lang="en-US"/>
+          </a:p>
+        </p:txBody>
+      </p:sp>
+    </p:spTree>
+    <p:extLst>
+      <p:ext uri="{BB962C8B-B14F-4D97-AF65-F5344CB8AC3E}">
+        <p14:creationId xmlns:p14="http://schemas.microsoft.com/office/powerpoint/2010/main" val="798466600"/>
+      </p:ext>
+    </p:extLst>
+  </p:cSld>
+  <p:clrMapOvr>
+    <a:masterClrMapping/>
+  </p:clrMapOvr>
 </p:sld>
 </file>
 
@@ -31862,6 +32059,20 @@
               <a:rPr lang="en-US" dirty="0"/>
               <a:t>/16</a:t>
             </a:r>
+          </a:p>
+          <a:p>
+            <a:r>
+              <a:rPr lang="en-US" dirty="0"/>
+              <a:t>CIDR enables more efficient </a:t>
+            </a:r>
+            <a:r>
+              <a:rPr lang="en-US" i="1" dirty="0"/>
+              <a:t>subnetting</a:t>
+            </a:r>
+            <a:endParaRPr lang="en-US" dirty="0"/>
+          </a:p>
+          <a:p>
+            <a:endParaRPr lang="en-US" dirty="0"/>
           </a:p>
         </p:txBody>
       </p:sp>
@@ -32553,6 +32764,37 @@
                                   </p:childTnLst>
                                 </p:cTn>
                               </p:par>
+                              <p:par>
+                                <p:cTn id="45" presetID="1" presetClass="entr" presetSubtype="0" fill="hold" nodeType="withEffect">
+                                  <p:stCondLst>
+                                    <p:cond delay="0"/>
+                                  </p:stCondLst>
+                                  <p:childTnLst>
+                                    <p:set>
+                                      <p:cBhvr>
+                                        <p:cTn id="46" dur="1" fill="hold">
+                                          <p:stCondLst>
+                                            <p:cond delay="0"/>
+                                          </p:stCondLst>
+                                        </p:cTn>
+                                        <p:tgtEl>
+                                          <p:spTgt spid="4">
+                                            <p:txEl>
+                                              <p:pRg st="5" end="5"/>
+                                            </p:txEl>
+                                          </p:spTgt>
+                                        </p:tgtEl>
+                                        <p:attrNameLst>
+                                          <p:attrName>style.visibility</p:attrName>
+                                        </p:attrNameLst>
+                                      </p:cBhvr>
+                                      <p:to>
+                                        <p:strVal val="visible"/>
+                                      </p:to>
+                                    </p:set>
+                                  </p:childTnLst>
+                                </p:cTn>
+                              </p:par>
                             </p:childTnLst>
                           </p:cTn>
                         </p:par>

</xml_diff>